<commit_message>
A7/A8 follow-up: the deck can now say SHA-256 and "shared", because both exist
Slide 12: "NEXT: SHA-256 fingerprint + dual signature" splits into a real tick for the
digest and a NEXT for the signatures, which did not land. Slides 1, 4, 5, 8, 15 and 16
restate it as what shipped: a SHA-256 over the findings, printed on every page, plus a
user-initiated share sheet.

Deliberately still NOT claimed anywhere: "signed", "tamper-proof", "both parties sign".

Co-Authored-By: Claude Opus 5 <noreply@anthropic.com>
Claude-Session: https://claude.ai/code/session_01PY1eWrVDnKYECRJ6N32uTn
</commit_message>
<xml_diff>
--- a/docs/pitch/SmartLease-Edge-iQOO-Hackathon-2026.pptx
+++ b/docs/pitch/SmartLease-Edge-iQOO-Hackathon-2026.pptx
@@ -5187,7 +5187,7 @@
                 </a:solidFill>
                 <a:latin typeface="Segoe UI"/>
               </a:rPr>
-              <a:t>OFFLINE PDF REPORT</a:t>
+              <a:t>SHA-256 PDF REPORT</a:t>
             </a:r>
           </a:p>
         </p:txBody>
@@ -14448,7 +14448,7 @@
                 </a:solidFill>
                 <a:latin typeface="Segoe UI"/>
               </a:rPr>
-              <a:t>NEXT:  SHA-256 fingerprint + dual signature</a:t>
+              <a:t>✓  SHA-256 of findings on every page   ·   NEXT: dual signature</a:t>
             </a:r>
           </a:p>
           <a:p>
@@ -19852,7 +19852,7 @@
                 </a:solidFill>
                 <a:latin typeface="Segoe UI"/>
               </a:rPr>
-              <a:t>Timestamped offline PDF report, generated on the phone</a:t>
+              <a:t>Offline PDF report carrying a SHA-256 of its own findings</a:t>
             </a:r>
           </a:p>
         </p:txBody>
@@ -21093,7 +21093,7 @@
                 </a:solidFill>
                 <a:latin typeface="Segoe UI"/>
               </a:rPr>
-              <a:t>No INTERNET permission in the manifest, allowBackup is off, and every backup domain is excluded, so the report PDF is not eligible for cloud backup either. No account, no analytics.</a:t>
+              <a:t>No INTERNET permission, allowBackup off, every backup domain excluded - the report PDF is not eligible for cloud backup. Sharing is a user-initiated share sheet, scoped to one file.</a:t>
             </a:r>
           </a:p>
         </p:txBody>
@@ -26330,7 +26330,7 @@
                 </a:solidFill>
                 <a:latin typeface="Segoe UI"/>
               </a:rPr>
-              <a:t>The findings are written into a plain-language PDF on the phone, with a timestamp and a session ID. Rule-based text today.</a:t>
+              <a:t>The findings are written into a plain-language PDF on the phone, with a timestamp and a SHA-256 of exactly those findings on every page. Rule-based text today.</a:t>
             </a:r>
           </a:p>
         </p:txBody>
@@ -28350,7 +28350,7 @@
                 </a:solidFill>
                 <a:latin typeface="Segoe UI"/>
               </a:rPr>
-              <a:t>Tap Generate. The findings render to a PDF on the phone in under a second, mirrored to the laptop through Office Kit.</a:t>
+              <a:t>Tap Generate. The findings render to a PDF on the phone in under a second, with their SHA-256 on every page, then straight to the share sheet.</a:t>
             </a:r>
           </a:p>
         </p:txBody>
@@ -31213,7 +31213,7 @@
                 </a:solidFill>
                 <a:latin typeface="Segoe UI"/>
               </a:rPr>
-              <a:t>- PDF render - Room DB</a:t>
+              <a:t>- PDF render - SHA-256 of findings - Room DB</a:t>
             </a:r>
           </a:p>
         </p:txBody>
@@ -31653,7 +31653,7 @@
                 </a:solidFill>
                 <a:latin typeface="Segoe UI"/>
               </a:rPr>
-              <a:t>OUTPUT   Offline PDF: timestamp + session ID, rendered on the phone. No cloud call at any stage, and no INTERNET permission in the manifest.</a:t>
+              <a:t>OUTPUT   Offline PDF: timestamp + session ID + SHA-256 of the findings on every page, rendered on the phone and shared by Intent or Office Kit. No cloud call at any stage, no INTERNET permission, backups disabled.</a:t>
             </a:r>
             <a:r>
               <a:rPr sz="1050" b="0" i="0">

</xml_diff>